<commit_message>
System Design 101 (vi): call the one-host process split an analogy in sd-08-012, qualify the off-host ratios in sd-08-013
Co-Authored-By: Claude Sonnet 5.5 <noreply@anthropic.com>
Claude-Session: https://claude.ai/code/session_01DkN7YTqFfdjb8A8J5ehSWS
</commit_message>
<xml_diff>
--- a/system-design-101/vi/lessons/sd-08-012/slides/sd-08-012.pptx
+++ b/system-design-101/vi/lessons/sd-08-012/slides/sd-08-012.pptx
@@ -5789,7 +5789,7 @@
               <a:buNone/>
             </a:pPr>
             <a:r>
-              <a:rPr lang="en-US" sz="2250" dirty="0" spc="-10" kern="0">
+              <a:rPr lang="en-US" sz="2250" dirty="0" spc="0" kern="0">
                 <a:solidFill>
                   <a:srgbClr val="FFB454"/>
                 </a:solidFill>
@@ -5797,10 +5797,10 @@
                 <a:ea typeface="Be Vietnam Pro ExtraBold" pitchFamily="34" charset="-122"/>
                 <a:cs typeface="Be Vietnam Pro ExtraBold" pitchFamily="34" charset="-120"/>
               </a:rPr>
-              <a:t>Mở</a:t>
-            </a:r>
-            <a:r>
-              <a:rPr lang="en-US" sz="2250" dirty="0" spc="-13" kern="0">
+              <a:t>Nhiều</a:t>
+            </a:r>
+            <a:r>
+              <a:rPr lang="en-US" sz="2250" dirty="0" spc="-2" kern="0">
                 <a:solidFill>
                   <a:srgbClr val="FFB454"/>
                 </a:solidFill>
@@ -5808,10 +5808,10 @@
                 <a:ea typeface="Be Vietnam Pro ExtraBold" pitchFamily="34" charset="-122"/>
                 <a:cs typeface="Be Vietnam Pro ExtraBold" pitchFamily="34" charset="-120"/>
               </a:rPr>
-              <a:t> rộng</a:t>
-            </a:r>
-            <a:r>
-              <a:rPr lang="en-US" sz="2250" dirty="0" spc="-5" kern="0">
+              <a:t> tiến</a:t>
+            </a:r>
+            <a:r>
+              <a:rPr lang="en-US" sz="2250" dirty="0" spc="7" kern="0">
                 <a:solidFill>
                   <a:srgbClr val="FFB454"/>
                 </a:solidFill>
@@ -5819,7 +5819,29 @@
                 <a:ea typeface="Be Vietnam Pro ExtraBold" pitchFamily="34" charset="-122"/>
                 <a:cs typeface="Be Vietnam Pro ExtraBold" pitchFamily="34" charset="-120"/>
               </a:rPr>
-              <a:t> ngang</a:t>
+              <a:t> trình,</a:t>
+            </a:r>
+            <a:r>
+              <a:rPr lang="en-US" sz="2250" dirty="0" spc="-7" kern="0">
+                <a:solidFill>
+                  <a:srgbClr val="FFB454"/>
+                </a:solidFill>
+                <a:latin typeface="Be Vietnam Pro ExtraBold" pitchFamily="34" charset="0"/>
+                <a:ea typeface="Be Vietnam Pro ExtraBold" pitchFamily="34" charset="-122"/>
+                <a:cs typeface="Be Vietnam Pro ExtraBold" pitchFamily="34" charset="-120"/>
+              </a:rPr>
+              <a:t> một</a:t>
+            </a:r>
+            <a:r>
+              <a:rPr lang="en-US" sz="2250" dirty="0" spc="-8" kern="0">
+                <a:solidFill>
+                  <a:srgbClr val="FFB454"/>
+                </a:solidFill>
+                <a:latin typeface="Be Vietnam Pro ExtraBold" pitchFamily="34" charset="0"/>
+                <a:ea typeface="Be Vietnam Pro ExtraBold" pitchFamily="34" charset="-122"/>
+                <a:cs typeface="Be Vietnam Pro ExtraBold" pitchFamily="34" charset="-120"/>
+              </a:rPr>
+              <a:t> máy</a:t>
             </a:r>
             <a:endParaRPr lang="en-US" sz="2250" dirty="0"/>
           </a:p>

</xml_diff>

<commit_message>
System Design 101 (vi): separate concurrent scheduling from async in sd-08-012
</commit_message>
<xml_diff>
--- a/system-design-101/vi/lessons/sd-08-012/slides/sd-08-012.pptx
+++ b/system-design-101/vi/lessons/sd-08-012/slides/sd-08-012.pptx
@@ -5637,7 +5637,18 @@
                 <a:ea typeface="Be Vietnam Pro" pitchFamily="34" charset="-122"/>
                 <a:cs typeface="Be Vietnam Pro" pitchFamily="34" charset="-120"/>
               </a:rPr>
-              <a:t> lần chờ:</a:t>
+              <a:t> lần chờ: lần</a:t>
+            </a:r>
+            <a:r>
+              <a:rPr lang="en-US" sz="2100" dirty="0" spc="3" kern="0">
+                <a:solidFill>
+                  <a:srgbClr val="E4E1D8"/>
+                </a:solidFill>
+                <a:latin typeface="Be Vietnam Pro" pitchFamily="34" charset="0"/>
+                <a:ea typeface="Be Vietnam Pro" pitchFamily="34" charset="-122"/>
+                <a:cs typeface="Be Vietnam Pro" pitchFamily="34" charset="-120"/>
+              </a:rPr>
+              <a:t> lượt</a:t>
             </a:r>
             <a:r>
               <a:rPr lang="en-US" sz="2100" dirty="0" spc="-4" kern="0">
@@ -5651,6 +5662,39 @@
               <a:t> 1,010</a:t>
             </a:r>
             <a:r>
+              <a:rPr lang="en-US" sz="2100" dirty="0" spc="0" kern="0">
+                <a:solidFill>
+                  <a:srgbClr val="E4E1D8"/>
+                </a:solidFill>
+                <a:latin typeface="Be Vietnam Pro" pitchFamily="34" charset="0"/>
+                <a:ea typeface="Be Vietnam Pro" pitchFamily="34" charset="-122"/>
+                <a:cs typeface="Be Vietnam Pro" pitchFamily="34" charset="-120"/>
+              </a:rPr>
+              <a:t> s,</a:t>
+            </a:r>
+            <a:r>
+              <a:rPr lang="en-US" sz="2100" dirty="0" spc="-8" kern="0">
+                <a:solidFill>
+                  <a:srgbClr val="E4E1D8"/>
+                </a:solidFill>
+                <a:latin typeface="Be Vietnam Pro" pitchFamily="34" charset="0"/>
+                <a:ea typeface="Be Vietnam Pro" pitchFamily="34" charset="-122"/>
+                <a:cs typeface="Be Vietnam Pro" pitchFamily="34" charset="-120"/>
+              </a:rPr>
+              <a:t> chạy</a:t>
+            </a:r>
+            <a:r>
+              <a:rPr lang="en-US" sz="2100" dirty="0" spc="7" kern="0">
+                <a:solidFill>
+                  <a:srgbClr val="E4E1D8"/>
+                </a:solidFill>
+                <a:latin typeface="Be Vietnam Pro" pitchFamily="34" charset="0"/>
+                <a:ea typeface="Be Vietnam Pro" pitchFamily="34" charset="-122"/>
+                <a:cs typeface="Be Vietnam Pro" pitchFamily="34" charset="-120"/>
+              </a:rPr>
+              <a:t> đồng</a:t>
+            </a:r>
+            <a:r>
               <a:rPr lang="en-US" sz="2100" dirty="0" spc="-1" kern="0">
                 <a:solidFill>
                   <a:srgbClr val="E4E1D8"/>
@@ -5659,10 +5703,10 @@
                 <a:ea typeface="Be Vietnam Pro" pitchFamily="34" charset="-122"/>
                 <a:cs typeface="Be Vietnam Pro" pitchFamily="34" charset="-120"/>
               </a:rPr>
-              <a:t> s</a:t>
-            </a:r>
-            <a:r>
-              <a:rPr lang="en-US" sz="2100" dirty="0" spc="-7" kern="0">
+              <a:t> thời</a:t>
+            </a:r>
+            <a:r>
+              <a:rPr lang="en-US" sz="2100" dirty="0" spc="-2" kern="0">
                 <a:solidFill>
                   <a:srgbClr val="E4E1D8"/>
                 </a:solidFill>
@@ -5670,10 +5714,10 @@
                 <a:ea typeface="Be Vietnam Pro" pitchFamily="34" charset="-122"/>
                 <a:cs typeface="Be Vietnam Pro" pitchFamily="34" charset="-120"/>
               </a:rPr>
-              <a:t> so</a:t>
-            </a:r>
-            <a:r>
-              <a:rPr lang="en-US" sz="2100" dirty="0" spc="-13" kern="0">
+              <a:t> 0,022</a:t>
+            </a:r>
+            <a:r>
+              <a:rPr lang="en-US" sz="2100" dirty="0" spc="0" kern="0">
                 <a:solidFill>
                   <a:srgbClr val="E4E1D8"/>
                 </a:solidFill>
@@ -5681,7 +5725,18 @@
                 <a:ea typeface="Be Vietnam Pro" pitchFamily="34" charset="-122"/>
                 <a:cs typeface="Be Vietnam Pro" pitchFamily="34" charset="-120"/>
               </a:rPr>
-              <a:t> với</a:t>
+              <a:t> s;</a:t>
+            </a:r>
+            <a:r>
+              <a:rPr lang="en-US" sz="2100" dirty="0" spc="-2" kern="0">
+                <a:solidFill>
+                  <a:srgbClr val="E4E1D8"/>
+                </a:solidFill>
+                <a:latin typeface="Be Vietnam Pro" pitchFamily="34" charset="0"/>
+                <a:ea typeface="Be Vietnam Pro" pitchFamily="34" charset="-122"/>
+                <a:cs typeface="Be Vietnam Pro" pitchFamily="34" charset="-120"/>
+              </a:rPr>
+              <a:t> việc nhỏ</a:t>
             </a:r>
             <a:r>
               <a:rPr lang="en-US" sz="2100" dirty="0" spc="-1" kern="0">
@@ -5692,10 +5747,10 @@
                 <a:ea typeface="Be Vietnam Pro" pitchFamily="34" charset="-122"/>
                 <a:cs typeface="Be Vietnam Pro" pitchFamily="34" charset="-120"/>
               </a:rPr>
-              <a:t> 0,022 s;</a:t>
-            </a:r>
-            <a:r>
-              <a:rPr lang="en-US" sz="2100" dirty="0" spc="-2" kern="0">
+              <a:t> chậm</a:t>
+            </a:r>
+            <a:r>
+              <a:rPr lang="en-US" sz="2100" dirty="0" spc="-3" kern="0">
                 <a:solidFill>
                   <a:srgbClr val="E4E1D8"/>
                 </a:solidFill>
@@ -5703,7 +5758,7 @@
                 <a:ea typeface="Be Vietnam Pro" pitchFamily="34" charset="-122"/>
                 <a:cs typeface="Be Vietnam Pro" pitchFamily="34" charset="-120"/>
               </a:rPr>
-              <a:t> việc nhỏ chậm 35</a:t>
+              <a:t> 35</a:t>
             </a:r>
             <a:r>
               <a:rPr lang="en-US" sz="2100" dirty="0" spc="12" kern="0">

</xml_diff>